<commit_message>
Restyle FDE joint TF slide to grayscale/steel-blue reference tone
Co-Authored-By: Claude Opus 5.5 <noreply@anthropic.com>
Claude-Session: https://claude.ai/code/session_014bmYQ2fMPYk9mSnunBW5W4
</commit_message>
<xml_diff>
--- a/FDE_공동TF_조직안.pptx
+++ b/FDE_공동TF_조직안.pptx
@@ -1131,14 +1131,21 @@
             <a:avLst/>
           </a:prstGeom>
           <a:solidFill>
-            <a:srgbClr val="F7F8FA"/>
+            <a:srgbClr val="FFFFFF"/>
           </a:solidFill>
           <a:ln w="9525">
             <a:solidFill>
-              <a:srgbClr val="D5D9E0"/>
+              <a:srgbClr val="D9D9D9"/>
             </a:solidFill>
             <a:prstDash val="solid"/>
           </a:ln>
+          <a:effectLst>
+            <a:outerShdw sx="100000" sy="100000" kx="0" ky="0" algn="bl" rotWithShape="0" blurRad="38100" dist="25400" dir="5400000">
+              <a:srgbClr val="999999">
+                <a:alpha val="35000"/>
+              </a:srgbClr>
+            </a:outerShdw>
+          </a:effectLst>
         </p:spPr>
       </p:sp>
       <p:sp>
@@ -1168,7 +1175,7 @@
             <a:r>
               <a:rPr lang="en-US" sz="1100" b="1" dirty="0">
                 <a:solidFill>
-                  <a:schemeClr val="tx1"/>
+                  <a:srgbClr val="404040"/>
                 </a:solidFill>
               </a:rPr>
               <a:t>그룹사</a:t>
@@ -1182,7 +1189,7 @@
             <a:r>
               <a:rPr lang="en-US" sz="1100" b="1" dirty="0">
                 <a:solidFill>
-                  <a:schemeClr val="tx1"/>
+                  <a:srgbClr val="404040"/>
                 </a:solidFill>
               </a:rPr>
               <a:t>Value</a:t>
@@ -1196,7 +1203,7 @@
             <a:r>
               <a:rPr lang="en-US" sz="1100" b="1" dirty="0">
                 <a:solidFill>
-                  <a:schemeClr val="tx1"/>
+                  <a:srgbClr val="404040"/>
                 </a:solidFill>
               </a:rPr>
               <a:t>Chain</a:t>
@@ -1220,9 +1227,16 @@
             <a:avLst/>
           </a:prstGeom>
           <a:solidFill>
-            <a:srgbClr val="8A94A6"/>
-          </a:solidFill>
-          <a:ln/>
+            <a:srgbClr val="B0B0B0"/>
+          </a:solidFill>
+          <a:ln/>
+          <a:effectLst>
+            <a:outerShdw sx="100000" sy="100000" kx="0" ky="0" algn="bl" rotWithShape="0" blurRad="25400" dist="19050" dir="5400000">
+              <a:srgbClr val="7F7F7F">
+                <a:alpha val="35000"/>
+              </a:srgbClr>
+            </a:outerShdw>
+          </a:effectLst>
         </p:spPr>
         <p:txBody>
           <a:bodyPr wrap="square" lIns="0" tIns="0" rIns="0" bIns="0" rtlCol="0" anchor="ctr"/>
@@ -1234,7 +1248,7 @@
             <a:r>
               <a:rPr lang="en-US" sz="1100" b="1" dirty="0">
                 <a:solidFill>
-                  <a:schemeClr val="bg1"/>
+                  <a:srgbClr val="FFFFFF"/>
                 </a:solidFill>
               </a:rPr>
               <a:t>R&amp;D</a:t>
@@ -1245,7 +1259,7 @@
             <a:r>
               <a:rPr lang="en-US" sz="900" dirty="0">
                 <a:solidFill>
-                  <a:schemeClr val="bg1"/>
+                  <a:srgbClr val="FFFFFF"/>
                 </a:solidFill>
               </a:rPr>
               <a:t>  11건</a:t>
@@ -1281,7 +1295,7 @@
             <a:r>
               <a:rPr lang="en-US" sz="900" dirty="0">
                 <a:solidFill>
-                  <a:schemeClr val="tx1"/>
+                  <a:srgbClr val="595959"/>
                 </a:solidFill>
               </a:rPr>
               <a:t>· PLM 고도화 (KT&amp;G)</a:t>
@@ -1295,7 +1309,7 @@
             <a:r>
               <a:rPr lang="en-US" sz="900" dirty="0">
                 <a:solidFill>
-                  <a:schemeClr val="tx1"/>
+                  <a:srgbClr val="595959"/>
                 </a:solidFill>
               </a:rPr>
               <a:t>· 연구·특허 문서 탐색</a:t>
@@ -1319,9 +1333,16 @@
             <a:avLst/>
           </a:prstGeom>
           <a:solidFill>
-            <a:srgbClr val="5B6B82"/>
-          </a:solidFill>
-          <a:ln/>
+            <a:srgbClr val="999999"/>
+          </a:solidFill>
+          <a:ln/>
+          <a:effectLst>
+            <a:outerShdw sx="100000" sy="100000" kx="0" ky="0" algn="bl" rotWithShape="0" blurRad="25400" dist="19050" dir="5400000">
+              <a:srgbClr val="7F7F7F">
+                <a:alpha val="35000"/>
+              </a:srgbClr>
+            </a:outerShdw>
+          </a:effectLst>
         </p:spPr>
         <p:txBody>
           <a:bodyPr wrap="square" lIns="0" tIns="0" rIns="0" bIns="0" rtlCol="0" anchor="ctr"/>
@@ -1333,7 +1354,7 @@
             <a:r>
               <a:rPr lang="en-US" sz="1100" b="1" dirty="0">
                 <a:solidFill>
-                  <a:schemeClr val="bg1"/>
+                  <a:srgbClr val="FFFFFF"/>
                 </a:solidFill>
               </a:rPr>
               <a:t>구매</a:t>
@@ -1344,7 +1365,7 @@
             <a:r>
               <a:rPr lang="en-US" sz="900" dirty="0">
                 <a:solidFill>
-                  <a:schemeClr val="bg1"/>
+                  <a:srgbClr val="FFFFFF"/>
                 </a:solidFill>
               </a:rPr>
               <a:t>  10건</a:t>
@@ -1380,7 +1401,7 @@
             <a:r>
               <a:rPr lang="en-US" sz="900" dirty="0">
                 <a:solidFill>
-                  <a:schemeClr val="tx1"/>
+                  <a:srgbClr val="595959"/>
                 </a:solidFill>
               </a:rPr>
               <a:t>· 수요예측 기반 발주</a:t>
@@ -1394,7 +1415,7 @@
             <a:r>
               <a:rPr lang="en-US" sz="900" dirty="0">
                 <a:solidFill>
-                  <a:schemeClr val="tx1"/>
+                  <a:srgbClr val="595959"/>
                 </a:solidFill>
               </a:rPr>
               <a:t>· 공급사 리스크 관리</a:t>
@@ -1418,9 +1439,16 @@
             <a:avLst/>
           </a:prstGeom>
           <a:solidFill>
-            <a:srgbClr val="8A94A6"/>
-          </a:solidFill>
-          <a:ln/>
+            <a:srgbClr val="808080"/>
+          </a:solidFill>
+          <a:ln/>
+          <a:effectLst>
+            <a:outerShdw sx="100000" sy="100000" kx="0" ky="0" algn="bl" rotWithShape="0" blurRad="25400" dist="19050" dir="5400000">
+              <a:srgbClr val="7F7F7F">
+                <a:alpha val="35000"/>
+              </a:srgbClr>
+            </a:outerShdw>
+          </a:effectLst>
         </p:spPr>
         <p:txBody>
           <a:bodyPr wrap="square" lIns="0" tIns="0" rIns="0" bIns="0" rtlCol="0" anchor="ctr"/>
@@ -1432,7 +1460,7 @@
             <a:r>
               <a:rPr lang="en-US" sz="1100" b="1" dirty="0">
                 <a:solidFill>
-                  <a:schemeClr val="bg1"/>
+                  <a:srgbClr val="FFFFFF"/>
                 </a:solidFill>
               </a:rPr>
               <a:t>생산</a:t>
@@ -1443,7 +1471,7 @@
             <a:r>
               <a:rPr lang="en-US" sz="900" dirty="0">
                 <a:solidFill>
-                  <a:schemeClr val="bg1"/>
+                  <a:srgbClr val="FFFFFF"/>
                 </a:solidFill>
               </a:rPr>
               <a:t>  9건</a:t>
@@ -1479,7 +1507,7 @@
             <a:r>
               <a:rPr lang="en-US" sz="900" dirty="0">
                 <a:solidFill>
-                  <a:schemeClr val="tx1"/>
+                  <a:srgbClr val="595959"/>
                 </a:solidFill>
               </a:rPr>
               <a:t>· 품질·불량 예측</a:t>
@@ -1493,7 +1521,7 @@
             <a:r>
               <a:rPr lang="en-US" sz="900" dirty="0">
                 <a:solidFill>
-                  <a:schemeClr val="tx1"/>
+                  <a:srgbClr val="595959"/>
                 </a:solidFill>
               </a:rPr>
               <a:t>· 설비 예지보전</a:t>
@@ -1517,9 +1545,16 @@
             <a:avLst/>
           </a:prstGeom>
           <a:solidFill>
-            <a:srgbClr val="5B6B82"/>
-          </a:solidFill>
-          <a:ln/>
+            <a:srgbClr val="666666"/>
+          </a:solidFill>
+          <a:ln/>
+          <a:effectLst>
+            <a:outerShdw sx="100000" sy="100000" kx="0" ky="0" algn="bl" rotWithShape="0" blurRad="25400" dist="19050" dir="5400000">
+              <a:srgbClr val="7F7F7F">
+                <a:alpha val="35000"/>
+              </a:srgbClr>
+            </a:outerShdw>
+          </a:effectLst>
         </p:spPr>
         <p:txBody>
           <a:bodyPr wrap="square" lIns="0" tIns="0" rIns="0" bIns="0" rtlCol="0" anchor="ctr"/>
@@ -1531,7 +1566,7 @@
             <a:r>
               <a:rPr lang="en-US" sz="1100" b="1" dirty="0">
                 <a:solidFill>
-                  <a:schemeClr val="bg1"/>
+                  <a:srgbClr val="FFFFFF"/>
                 </a:solidFill>
               </a:rPr>
               <a:t>물류</a:t>
@@ -1542,7 +1577,7 @@
             <a:r>
               <a:rPr lang="en-US" sz="900" dirty="0">
                 <a:solidFill>
-                  <a:schemeClr val="bg1"/>
+                  <a:srgbClr val="FFFFFF"/>
                 </a:solidFill>
               </a:rPr>
               <a:t>  13건</a:t>
@@ -1578,7 +1613,7 @@
             <a:r>
               <a:rPr lang="en-US" sz="900" dirty="0">
                 <a:solidFill>
-                  <a:schemeClr val="tx1"/>
+                  <a:srgbClr val="595959"/>
                 </a:solidFill>
               </a:rPr>
               <a:t>· 물류 운영 최적화</a:t>
@@ -1592,7 +1627,7 @@
             <a:r>
               <a:rPr lang="en-US" sz="900" dirty="0">
                 <a:solidFill>
-                  <a:schemeClr val="tx1"/>
+                  <a:srgbClr val="595959"/>
                 </a:solidFill>
               </a:rPr>
               <a:t>· 센터 자동화 운영</a:t>
@@ -1616,9 +1651,16 @@
             <a:avLst/>
           </a:prstGeom>
           <a:solidFill>
-            <a:srgbClr val="8A94A6"/>
-          </a:solidFill>
-          <a:ln/>
+            <a:srgbClr val="4D4D4D"/>
+          </a:solidFill>
+          <a:ln/>
+          <a:effectLst>
+            <a:outerShdw sx="100000" sy="100000" kx="0" ky="0" algn="bl" rotWithShape="0" blurRad="25400" dist="19050" dir="5400000">
+              <a:srgbClr val="7F7F7F">
+                <a:alpha val="35000"/>
+              </a:srgbClr>
+            </a:outerShdw>
+          </a:effectLst>
         </p:spPr>
         <p:txBody>
           <a:bodyPr wrap="square" lIns="0" tIns="0" rIns="0" bIns="0" rtlCol="0" anchor="ctr"/>
@@ -1630,7 +1672,7 @@
             <a:r>
               <a:rPr lang="en-US" sz="1100" b="1" dirty="0">
                 <a:solidFill>
-                  <a:schemeClr val="bg1"/>
+                  <a:srgbClr val="FFFFFF"/>
                 </a:solidFill>
               </a:rPr>
               <a:t>영업·마케팅</a:t>
@@ -1641,7 +1683,7 @@
             <a:r>
               <a:rPr lang="en-US" sz="900" dirty="0">
                 <a:solidFill>
-                  <a:schemeClr val="bg1"/>
+                  <a:srgbClr val="FFFFFF"/>
                 </a:solidFill>
               </a:rPr>
               <a:t>  40건</a:t>
@@ -1677,7 +1719,7 @@
             <a:r>
               <a:rPr lang="en-US" sz="900" dirty="0">
                 <a:solidFill>
-                  <a:schemeClr val="tx1"/>
+                  <a:srgbClr val="595959"/>
                 </a:solidFill>
               </a:rPr>
               <a:t>· 객실요금 최적화 (호텔)</a:t>
@@ -1691,7 +1733,7 @@
             <a:r>
               <a:rPr lang="en-US" sz="900" dirty="0">
                 <a:solidFill>
-                  <a:schemeClr val="tx1"/>
+                  <a:srgbClr val="595959"/>
                 </a:solidFill>
               </a:rPr>
               <a:t>· 브랜드 AI포탈 (백화점)</a:t>
@@ -1715,9 +1757,16 @@
             <a:avLst/>
           </a:prstGeom>
           <a:solidFill>
-            <a:srgbClr val="5B6B82"/>
-          </a:solidFill>
-          <a:ln/>
+            <a:srgbClr val="333F50"/>
+          </a:solidFill>
+          <a:ln/>
+          <a:effectLst>
+            <a:outerShdw sx="100000" sy="100000" kx="0" ky="0" algn="bl" rotWithShape="0" blurRad="25400" dist="19050" dir="5400000">
+              <a:srgbClr val="7F7F7F">
+                <a:alpha val="35000"/>
+              </a:srgbClr>
+            </a:outerShdw>
+          </a:effectLst>
         </p:spPr>
         <p:txBody>
           <a:bodyPr wrap="square" lIns="0" tIns="0" rIns="0" bIns="0" rtlCol="0" anchor="ctr"/>
@@ -1729,7 +1778,7 @@
             <a:r>
               <a:rPr lang="en-US" sz="1100" b="1" dirty="0">
                 <a:solidFill>
-                  <a:schemeClr val="bg1"/>
+                  <a:srgbClr val="FFFFFF"/>
                 </a:solidFill>
               </a:rPr>
               <a:t>경영관리</a:t>
@@ -1740,7 +1789,7 @@
             <a:r>
               <a:rPr lang="en-US" sz="900" dirty="0">
                 <a:solidFill>
-                  <a:schemeClr val="bg1"/>
+                  <a:srgbClr val="FFFFFF"/>
                 </a:solidFill>
               </a:rPr>
               <a:t>  25건</a:t>
@@ -1776,7 +1825,7 @@
             <a:r>
               <a:rPr lang="en-US" sz="900" dirty="0">
                 <a:solidFill>
-                  <a:schemeClr val="tx1"/>
+                  <a:srgbClr val="595959"/>
                 </a:solidFill>
               </a:rPr>
               <a:t>· AI 문서탐색 (물산)</a:t>
@@ -1790,7 +1839,7 @@
             <a:r>
               <a:rPr lang="en-US" sz="900" dirty="0">
                 <a:solidFill>
-                  <a:schemeClr val="tx1"/>
+                  <a:srgbClr val="595959"/>
                 </a:solidFill>
               </a:rPr>
               <a:t>· KPI 성과관리 (마트)</a:t>
@@ -1850,11 +1899,11 @@
             <a:avLst/>
           </a:prstGeom>
           <a:solidFill>
-            <a:srgbClr val="F7F8FA"/>
-          </a:solidFill>
-          <a:ln w="9525">
+            <a:srgbClr val="EDEDED"/>
+          </a:solidFill>
+          <a:ln w="12700">
             <a:solidFill>
-              <a:srgbClr val="D5D9E0"/>
+              <a:srgbClr val="EDEDED"/>
             </a:solidFill>
             <a:prstDash val="solid"/>
           </a:ln>
@@ -1887,7 +1936,7 @@
             <a:r>
               <a:rPr lang="en-US" sz="1200" b="1" u="sng" dirty="0">
                 <a:solidFill>
-                  <a:schemeClr val="tx1"/>
+                  <a:srgbClr val="262626"/>
                 </a:solidFill>
               </a:rPr>
               <a:t>FDE 수행 체계 및 그룹사 제공 서비스</a:t>
@@ -1907,15 +1956,17 @@
             <a:off x="548640" y="3310128"/>
             <a:ext cx="1920240" cy="2944368"/>
           </a:xfrm>
-          <a:prstGeom prst="rect">
-            <a:avLst/>
-          </a:prstGeom>
-          <a:solidFill>
-            <a:schemeClr val="bg1"/>
-          </a:solidFill>
-          <a:ln w="9525">
+          <a:prstGeom prst="roundRect">
+            <a:avLst>
+              <a:gd name="adj" fmla="val 3810"/>
+            </a:avLst>
+          </a:prstGeom>
+          <a:solidFill>
+            <a:srgbClr val="FFFFFF"/>
+          </a:solidFill>
+          <a:ln w="12700">
             <a:solidFill>
-              <a:srgbClr val="BFC5CF"/>
+              <a:srgbClr val="D9D9D9"/>
             </a:solidFill>
             <a:prstDash val="solid"/>
           </a:ln>
@@ -1948,7 +1999,7 @@
             <a:r>
               <a:rPr lang="en-US" sz="1100" b="1" dirty="0">
                 <a:solidFill>
-                  <a:schemeClr val="tx2"/>
+                  <a:srgbClr val="595959"/>
                 </a:solidFill>
               </a:rPr>
               <a:t>엔지니어 협업 (Tech)</a:t>
@@ -1974,7 +2025,7 @@
             </a:avLst>
           </a:prstGeom>
           <a:solidFill>
-            <a:srgbClr val="6B7280"/>
+            <a:srgbClr val="A6A6A6"/>
           </a:solidFill>
           <a:ln/>
           <a:effectLst>
@@ -1995,7 +2046,7 @@
             <a:r>
               <a:rPr lang="en-US" sz="1300" b="1" dirty="0">
                 <a:solidFill>
-                  <a:schemeClr val="bg1"/>
+                  <a:srgbClr val="FFFFFF"/>
                 </a:solidFill>
               </a:rPr>
               <a:t>AI혁신센터</a:t>
@@ -2009,7 +2060,7 @@
             <a:r>
               <a:rPr lang="en-US" sz="900" dirty="0">
                 <a:solidFill>
-                  <a:schemeClr val="bg1"/>
+                  <a:srgbClr val="FFFFFF"/>
                 </a:solidFill>
               </a:rPr>
               <a:t>AI 모델 · Agent 개발</a:t>
@@ -2035,7 +2086,7 @@
             </a:avLst>
           </a:prstGeom>
           <a:solidFill>
-            <a:srgbClr val="4A5260"/>
+            <a:srgbClr val="4D4D4D"/>
           </a:solidFill>
           <a:ln/>
           <a:effectLst>
@@ -2056,7 +2107,7 @@
             <a:r>
               <a:rPr lang="en-US" sz="1300" b="1" dirty="0">
                 <a:solidFill>
-                  <a:schemeClr val="bg1"/>
+                  <a:srgbClr val="FFFFFF"/>
                 </a:solidFill>
               </a:rPr>
               <a:t>D&amp;AX부문</a:t>
@@ -2070,7 +2121,7 @@
             <a:r>
               <a:rPr lang="en-US" sz="900" dirty="0">
                 <a:solidFill>
-                  <a:schemeClr val="bg1"/>
+                  <a:srgbClr val="FFFFFF"/>
                 </a:solidFill>
               </a:rPr>
               <a:t>데이터 · 플랫폼</a:t>
@@ -2084,7 +2135,7 @@
             <a:r>
               <a:rPr lang="en-US" sz="900" dirty="0">
                 <a:solidFill>
-                  <a:schemeClr val="bg1"/>
+                  <a:srgbClr val="FFFFFF"/>
                 </a:solidFill>
               </a:rPr>
               <a:t>기간계 연동</a:t>
@@ -2110,758 +2161,7 @@
             </a:avLst>
           </a:prstGeom>
           <a:solidFill>
-            <a:schemeClr val="accent2"/>
-          </a:solidFill>
-          <a:ln/>
-        </p:spPr>
-        <p:txBody>
-          <a:bodyPr wrap="square" lIns="0" tIns="0" rIns="0" bIns="0" rtlCol="0" anchor="ctr"/>
-          <a:lstStyle/>
-          <a:p>
-            <a:pPr algn="ctr" indent="0" marL="0">
-              <a:buNone/>
-            </a:pPr>
-            <a:r>
-              <a:rPr lang="en-US" sz="1100" b="1" dirty="0">
-                <a:solidFill>
-                  <a:schemeClr val="bg1"/>
-                </a:solidFill>
-              </a:rPr>
-              <a:t>MVP 구축 · 운영 이관</a:t>
-            </a:r>
-            <a:endParaRPr lang="en-US" sz="1100" dirty="0"/>
-          </a:p>
-        </p:txBody>
-      </p:sp>
-      <p:sp>
-        <p:nvSpPr>
-          <p:cNvPr id="27" name="Text 25"/>
-          <p:cNvSpPr txBox="1"/>
-          <p:nvPr/>
-        </p:nvSpPr>
-        <p:spPr>
-          <a:xfrm>
-            <a:off x="2487168" y="4434840"/>
-            <a:ext cx="548640" cy="548640"/>
-          </a:xfrm>
-          <a:prstGeom prst="rect">
-            <a:avLst/>
-          </a:prstGeom>
-          <a:noFill/>
-          <a:ln/>
-        </p:spPr>
-        <p:txBody>
-          <a:bodyPr wrap="square" lIns="0" tIns="0" rIns="0" bIns="0" rtlCol="0" anchor="ctr"/>
-          <a:lstStyle/>
-          <a:p>
-            <a:pPr algn="ctr" indent="0" marL="0">
-              <a:buNone/>
-            </a:pPr>
-            <a:r>
-              <a:rPr lang="en-US" sz="3000" b="1" dirty="0">
-                <a:solidFill>
-                  <a:schemeClr val="accent3"/>
-                </a:solidFill>
-              </a:rPr>
-              <a:t>+</a:t>
-            </a:r>
-            <a:endParaRPr lang="en-US" sz="3000" dirty="0"/>
-          </a:p>
-        </p:txBody>
-      </p:sp>
-      <p:sp>
-        <p:nvSpPr>
-          <p:cNvPr id="28" name="Biz 그룹 박스"/>
-          <p:cNvSpPr/>
-          <p:nvPr/>
-        </p:nvSpPr>
-        <p:spPr>
-          <a:xfrm>
-            <a:off x="3035808" y="3310128"/>
-            <a:ext cx="5074920" cy="2944368"/>
-          </a:xfrm>
-          <a:prstGeom prst="roundRect">
-            <a:avLst>
-              <a:gd name="adj" fmla="val 1863"/>
-            </a:avLst>
-          </a:prstGeom>
-          <a:solidFill>
-            <a:schemeClr val="bg1"/>
-          </a:solidFill>
-          <a:ln w="9525">
-            <a:solidFill>
-              <a:srgbClr val="BFC5CF"/>
-            </a:solidFill>
-            <a:prstDash val="solid"/>
-          </a:ln>
-        </p:spPr>
-      </p:sp>
-      <p:sp>
-        <p:nvSpPr>
-          <p:cNvPr id="29" name="Text 27"/>
-          <p:cNvSpPr txBox="1"/>
-          <p:nvPr/>
-        </p:nvSpPr>
-        <p:spPr>
-          <a:xfrm>
-            <a:off x="3035808" y="3346704"/>
-            <a:ext cx="5074920" cy="292608"/>
-          </a:xfrm>
-          <a:prstGeom prst="rect">
-            <a:avLst/>
-          </a:prstGeom>
-          <a:noFill/>
-          <a:ln/>
-        </p:spPr>
-        <p:txBody>
-          <a:bodyPr wrap="square" lIns="0" tIns="0" rIns="0" bIns="0" rtlCol="0" anchor="ctr"/>
-          <a:lstStyle/>
-          <a:p>
-            <a:pPr algn="ctr" indent="0" marL="0">
-              <a:buNone/>
-            </a:pPr>
-            <a:r>
-              <a:rPr lang="en-US" sz="1100" b="1" dirty="0">
-                <a:solidFill>
-                  <a:schemeClr val="tx2"/>
-                </a:solidFill>
-              </a:rPr>
-              <a:t>Biz 그룹 (문제정의 · 적용설계)</a:t>
-            </a:r>
-            <a:endParaRPr lang="en-US" sz="1100" dirty="0"/>
-          </a:p>
-        </p:txBody>
-      </p:sp>
-      <p:sp>
-        <p:nvSpPr>
-          <p:cNvPr id="30" name="팀 AX컨설팅팀"/>
-          <p:cNvSpPr txBox="1"/>
-          <p:nvPr/>
-        </p:nvSpPr>
-        <p:spPr>
-          <a:xfrm>
-            <a:off x="3145536" y="3703320"/>
-            <a:ext cx="2377440" cy="310896"/>
-          </a:xfrm>
-          <a:prstGeom prst="rect">
-            <a:avLst/>
-          </a:prstGeom>
-          <a:solidFill>
-            <a:srgbClr val="1F4E9A"/>
-          </a:solidFill>
-          <a:ln/>
-        </p:spPr>
-        <p:txBody>
-          <a:bodyPr wrap="square" lIns="0" tIns="0" rIns="0" bIns="0" rtlCol="0" anchor="ctr"/>
-          <a:lstStyle/>
-          <a:p>
-            <a:pPr algn="ctr" indent="0" marL="0">
-              <a:buNone/>
-            </a:pPr>
-            <a:r>
-              <a:rPr lang="en-US" sz="1150" b="1" dirty="0">
-                <a:solidFill>
-                  <a:srgbClr val="FFFFFF"/>
-                </a:solidFill>
-              </a:rPr>
-              <a:t>AX컨설팅팀</a:t>
-            </a:r>
-            <a:endParaRPr lang="en-US" sz="1150" dirty="0"/>
-          </a:p>
-        </p:txBody>
-      </p:sp>
-      <p:sp>
-        <p:nvSpPr>
-          <p:cNvPr id="31" name="Text 29"/>
-          <p:cNvSpPr txBox="1"/>
-          <p:nvPr/>
-        </p:nvSpPr>
-        <p:spPr>
-          <a:xfrm>
-            <a:off x="3145536" y="4069080"/>
-            <a:ext cx="1161288" cy="301752"/>
-          </a:xfrm>
-          <a:prstGeom prst="rect">
-            <a:avLst/>
-          </a:prstGeom>
-          <a:solidFill>
-            <a:srgbClr val="6B7FA8"/>
-          </a:solidFill>
-          <a:ln/>
-        </p:spPr>
-        <p:txBody>
-          <a:bodyPr wrap="square" lIns="0" tIns="0" rIns="0" bIns="0" rtlCol="0" anchor="ctr"/>
-          <a:lstStyle/>
-          <a:p>
-            <a:pPr algn="ctr" indent="0" marL="0">
-              <a:buNone/>
-            </a:pPr>
-            <a:r>
-              <a:rPr lang="en-US" sz="950" b="1" dirty="0">
-                <a:solidFill>
-                  <a:srgbClr val="FFFFFF"/>
-                </a:solidFill>
-              </a:rPr>
-              <a:t>진단/발굴 9건</a:t>
-            </a:r>
-            <a:endParaRPr lang="en-US" sz="950" dirty="0"/>
-          </a:p>
-        </p:txBody>
-      </p:sp>
-      <p:sp>
-        <p:nvSpPr>
-          <p:cNvPr id="32" name="Text 30"/>
-          <p:cNvSpPr txBox="1"/>
-          <p:nvPr/>
-        </p:nvSpPr>
-        <p:spPr>
-          <a:xfrm>
-            <a:off x="4361688" y="4069080"/>
-            <a:ext cx="1161288" cy="301752"/>
-          </a:xfrm>
-          <a:prstGeom prst="rect">
-            <a:avLst/>
-          </a:prstGeom>
-          <a:solidFill>
-            <a:srgbClr val="6B7FA8"/>
-          </a:solidFill>
-          <a:ln/>
-        </p:spPr>
-        <p:txBody>
-          <a:bodyPr wrap="square" lIns="0" tIns="0" rIns="0" bIns="0" rtlCol="0" anchor="ctr"/>
-          <a:lstStyle/>
-          <a:p>
-            <a:pPr algn="ctr" indent="0" marL="0">
-              <a:buNone/>
-            </a:pPr>
-            <a:r>
-              <a:rPr lang="en-US" sz="950" b="1" dirty="0">
-                <a:solidFill>
-                  <a:srgbClr val="FFFFFF"/>
-                </a:solidFill>
-              </a:rPr>
-              <a:t>전략수립 4건</a:t>
-            </a:r>
-            <a:endParaRPr lang="en-US" sz="950" dirty="0"/>
-          </a:p>
-        </p:txBody>
-      </p:sp>
-      <p:sp>
-        <p:nvSpPr>
-          <p:cNvPr id="33" name="Text 31"/>
-          <p:cNvSpPr txBox="1"/>
-          <p:nvPr/>
-        </p:nvSpPr>
-        <p:spPr>
-          <a:xfrm>
-            <a:off x="3145536" y="4407408"/>
-            <a:ext cx="1161288" cy="301752"/>
-          </a:xfrm>
-          <a:prstGeom prst="rect">
-            <a:avLst/>
-          </a:prstGeom>
-          <a:solidFill>
-            <a:srgbClr val="6B7FA8"/>
-          </a:solidFill>
-          <a:ln/>
-        </p:spPr>
-        <p:txBody>
-          <a:bodyPr wrap="square" lIns="0" tIns="0" rIns="0" bIns="0" rtlCol="0" anchor="ctr"/>
-          <a:lstStyle/>
-          <a:p>
-            <a:pPr algn="ctr" indent="0" marL="0">
-              <a:buNone/>
-            </a:pPr>
-            <a:r>
-              <a:rPr lang="en-US" sz="950" b="1" dirty="0">
-                <a:solidFill>
-                  <a:srgbClr val="FFFFFF"/>
-                </a:solidFill>
-              </a:rPr>
-              <a:t>특화영역 3건</a:t>
-            </a:r>
-            <a:endParaRPr lang="en-US" sz="950" dirty="0"/>
-          </a:p>
-        </p:txBody>
-      </p:sp>
-      <p:sp>
-        <p:nvSpPr>
-          <p:cNvPr id="34" name="Text 32"/>
-          <p:cNvSpPr txBox="1"/>
-          <p:nvPr/>
-        </p:nvSpPr>
-        <p:spPr>
-          <a:xfrm>
-            <a:off x="4361688" y="4407408"/>
-            <a:ext cx="1161288" cy="301752"/>
-          </a:xfrm>
-          <a:prstGeom prst="rect">
-            <a:avLst/>
-          </a:prstGeom>
-          <a:solidFill>
-            <a:srgbClr val="6B7FA8"/>
-          </a:solidFill>
-          <a:ln/>
-        </p:spPr>
-        <p:txBody>
-          <a:bodyPr wrap="square" lIns="0" tIns="0" rIns="0" bIns="0" rtlCol="0" anchor="ctr"/>
-          <a:lstStyle/>
-          <a:p>
-            <a:pPr algn="ctr" indent="0" marL="0">
-              <a:buNone/>
-            </a:pPr>
-            <a:r>
-              <a:rPr lang="en-US" sz="950" b="1" dirty="0">
-                <a:solidFill>
-                  <a:srgbClr val="FFFFFF"/>
-                </a:solidFill>
-              </a:rPr>
-              <a:t>AX교육 6건</a:t>
-            </a:r>
-            <a:endParaRPr lang="en-US" sz="950" dirty="0"/>
-          </a:p>
-        </p:txBody>
-      </p:sp>
-      <p:sp>
-        <p:nvSpPr>
-          <p:cNvPr id="35" name="Text 33"/>
-          <p:cNvSpPr txBox="1"/>
-          <p:nvPr/>
-        </p:nvSpPr>
-        <p:spPr>
-          <a:xfrm>
-            <a:off x="3145536" y="4791456"/>
-            <a:ext cx="2377440" cy="365760"/>
-          </a:xfrm>
-          <a:prstGeom prst="rect">
-            <a:avLst/>
-          </a:prstGeom>
-          <a:solidFill>
-            <a:srgbClr val="EEF0F3"/>
-          </a:solidFill>
-          <a:ln/>
-        </p:spPr>
-        <p:txBody>
-          <a:bodyPr wrap="square" lIns="0" tIns="0" rIns="0" bIns="0" rtlCol="0" anchor="ctr"/>
-          <a:lstStyle/>
-          <a:p>
-            <a:pPr algn="ctr" indent="0" marL="0">
-              <a:buNone/>
-            </a:pPr>
-            <a:r>
-              <a:rPr lang="en-US" sz="950" b="1" dirty="0">
-                <a:solidFill>
-                  <a:schemeClr val="tx1"/>
-                </a:solidFill>
-              </a:rPr>
-              <a:t>그룹사 AI컨설팅 수행 경험</a:t>
-            </a:r>
-            <a:endParaRPr lang="en-US" sz="950" dirty="0"/>
-          </a:p>
-        </p:txBody>
-      </p:sp>
-      <p:sp>
-        <p:nvSpPr>
-          <p:cNvPr id="36" name="Text 34"/>
-          <p:cNvSpPr txBox="1"/>
-          <p:nvPr/>
-        </p:nvSpPr>
-        <p:spPr>
-          <a:xfrm>
-            <a:off x="3145536" y="5212080"/>
-            <a:ext cx="2377440" cy="365760"/>
-          </a:xfrm>
-          <a:prstGeom prst="rect">
-            <a:avLst/>
-          </a:prstGeom>
-          <a:solidFill>
-            <a:srgbClr val="FFF9C4"/>
-          </a:solidFill>
-          <a:ln w="6350">
-            <a:solidFill>
-              <a:srgbClr val="D5D9E0"/>
-            </a:solidFill>
-          </a:ln>
-        </p:spPr>
-        <p:txBody>
-          <a:bodyPr wrap="square" lIns="0" tIns="0" rIns="0" bIns="0" rtlCol="0" anchor="ctr"/>
-          <a:lstStyle/>
-          <a:p>
-            <a:pPr algn="ctr" indent="0" marL="0">
-              <a:buNone/>
-            </a:pPr>
-            <a:r>
-              <a:rPr lang="en-US" sz="1000" b="1" dirty="0">
-                <a:solidFill>
-                  <a:schemeClr val="tx1"/>
-                </a:solidFill>
-              </a:rPr>
-              <a:t>AI추진과제 Pool 108건</a:t>
-            </a:r>
-            <a:endParaRPr lang="en-US" sz="1000" dirty="0"/>
-          </a:p>
-        </p:txBody>
-      </p:sp>
-      <p:sp>
-        <p:nvSpPr>
-          <p:cNvPr id="37" name="팀 Biz컨설팅팀"/>
-          <p:cNvSpPr txBox="1"/>
-          <p:nvPr/>
-        </p:nvSpPr>
-        <p:spPr>
-          <a:xfrm>
-            <a:off x="5614416" y="3703320"/>
-            <a:ext cx="2377440" cy="310896"/>
-          </a:xfrm>
-          <a:prstGeom prst="rect">
-            <a:avLst/>
-          </a:prstGeom>
-          <a:solidFill>
-            <a:srgbClr val="0F7B6C"/>
-          </a:solidFill>
-          <a:ln/>
-        </p:spPr>
-        <p:txBody>
-          <a:bodyPr wrap="square" lIns="0" tIns="0" rIns="0" bIns="0" rtlCol="0" anchor="ctr"/>
-          <a:lstStyle/>
-          <a:p>
-            <a:pPr algn="ctr" indent="0" marL="0">
-              <a:buNone/>
-            </a:pPr>
-            <a:r>
-              <a:rPr lang="en-US" sz="1150" b="1" dirty="0">
-                <a:solidFill>
-                  <a:srgbClr val="FFFFFF"/>
-                </a:solidFill>
-              </a:rPr>
-              <a:t>Biz컨설팅팀</a:t>
-            </a:r>
-            <a:endParaRPr lang="en-US" sz="1150" dirty="0"/>
-          </a:p>
-        </p:txBody>
-      </p:sp>
-      <p:sp>
-        <p:nvSpPr>
-          <p:cNvPr id="38" name="Text 36"/>
-          <p:cNvSpPr txBox="1"/>
-          <p:nvPr/>
-        </p:nvSpPr>
-        <p:spPr>
-          <a:xfrm>
-            <a:off x="5614416" y="4069080"/>
-            <a:ext cx="1161288" cy="301752"/>
-          </a:xfrm>
-          <a:prstGeom prst="rect">
-            <a:avLst/>
-          </a:prstGeom>
-          <a:solidFill>
-            <a:srgbClr val="5E8C84"/>
-          </a:solidFill>
-          <a:ln/>
-        </p:spPr>
-        <p:txBody>
-          <a:bodyPr wrap="square" lIns="0" tIns="0" rIns="0" bIns="0" rtlCol="0" anchor="ctr"/>
-          <a:lstStyle/>
-          <a:p>
-            <a:pPr algn="ctr" indent="0" marL="0">
-              <a:buNone/>
-            </a:pPr>
-            <a:r>
-              <a:rPr lang="en-US" sz="950" b="1" dirty="0">
-                <a:solidFill>
-                  <a:srgbClr val="FFFFFF"/>
-                </a:solidFill>
-              </a:rPr>
-              <a:t>식품/제조</a:t>
-            </a:r>
-            <a:endParaRPr lang="en-US" sz="950" dirty="0"/>
-          </a:p>
-        </p:txBody>
-      </p:sp>
-      <p:sp>
-        <p:nvSpPr>
-          <p:cNvPr id="39" name="Text 37"/>
-          <p:cNvSpPr txBox="1"/>
-          <p:nvPr/>
-        </p:nvSpPr>
-        <p:spPr>
-          <a:xfrm>
-            <a:off x="6830568" y="4069080"/>
-            <a:ext cx="1161288" cy="301752"/>
-          </a:xfrm>
-          <a:prstGeom prst="rect">
-            <a:avLst/>
-          </a:prstGeom>
-          <a:solidFill>
-            <a:srgbClr val="5E8C84"/>
-          </a:solidFill>
-          <a:ln/>
-        </p:spPr>
-        <p:txBody>
-          <a:bodyPr wrap="square" lIns="0" tIns="0" rIns="0" bIns="0" rtlCol="0" anchor="ctr"/>
-          <a:lstStyle/>
-          <a:p>
-            <a:pPr algn="ctr" indent="0" marL="0">
-              <a:buNone/>
-            </a:pPr>
-            <a:r>
-              <a:rPr lang="en-US" sz="950" b="1" dirty="0">
-                <a:solidFill>
-                  <a:srgbClr val="FFFFFF"/>
-                </a:solidFill>
-              </a:rPr>
-              <a:t>유통</a:t>
-            </a:r>
-            <a:endParaRPr lang="en-US" sz="950" dirty="0"/>
-          </a:p>
-        </p:txBody>
-      </p:sp>
-      <p:sp>
-        <p:nvSpPr>
-          <p:cNvPr id="40" name="Text 38"/>
-          <p:cNvSpPr txBox="1"/>
-          <p:nvPr/>
-        </p:nvSpPr>
-        <p:spPr>
-          <a:xfrm>
-            <a:off x="5614416" y="4407408"/>
-            <a:ext cx="1161288" cy="301752"/>
-          </a:xfrm>
-          <a:prstGeom prst="rect">
-            <a:avLst/>
-          </a:prstGeom>
-          <a:solidFill>
-            <a:srgbClr val="5E8C84"/>
-          </a:solidFill>
-          <a:ln/>
-        </p:spPr>
-        <p:txBody>
-          <a:bodyPr wrap="square" lIns="0" tIns="0" rIns="0" bIns="0" rtlCol="0" anchor="ctr"/>
-          <a:lstStyle/>
-          <a:p>
-            <a:pPr algn="ctr" indent="0" marL="0">
-              <a:buNone/>
-            </a:pPr>
-            <a:r>
-              <a:rPr lang="en-US" sz="950" b="1" dirty="0">
-                <a:solidFill>
-                  <a:srgbClr val="FFFFFF"/>
-                </a:solidFill>
-              </a:rPr>
-              <a:t>화학/건설</a:t>
-            </a:r>
-            <a:endParaRPr lang="en-US" sz="950" dirty="0"/>
-          </a:p>
-        </p:txBody>
-      </p:sp>
-      <p:sp>
-        <p:nvSpPr>
-          <p:cNvPr id="41" name="Text 39"/>
-          <p:cNvSpPr txBox="1"/>
-          <p:nvPr/>
-        </p:nvSpPr>
-        <p:spPr>
-          <a:xfrm>
-            <a:off x="6830568" y="4407408"/>
-            <a:ext cx="1161288" cy="301752"/>
-          </a:xfrm>
-          <a:prstGeom prst="rect">
-            <a:avLst/>
-          </a:prstGeom>
-          <a:solidFill>
-            <a:srgbClr val="5E8C84"/>
-          </a:solidFill>
-          <a:ln/>
-        </p:spPr>
-        <p:txBody>
-          <a:bodyPr wrap="square" lIns="0" tIns="0" rIns="0" bIns="0" rtlCol="0" anchor="ctr"/>
-          <a:lstStyle/>
-          <a:p>
-            <a:pPr algn="ctr" indent="0" marL="0">
-              <a:buNone/>
-            </a:pPr>
-            <a:r>
-              <a:rPr lang="en-US" sz="950" b="1" dirty="0">
-                <a:solidFill>
-                  <a:srgbClr val="FFFFFF"/>
-                </a:solidFill>
-              </a:rPr>
-              <a:t>호텔/서비스</a:t>
-            </a:r>
-            <a:endParaRPr lang="en-US" sz="950" dirty="0"/>
-          </a:p>
-        </p:txBody>
-      </p:sp>
-      <p:sp>
-        <p:nvSpPr>
-          <p:cNvPr id="42" name="Text 40"/>
-          <p:cNvSpPr txBox="1"/>
-          <p:nvPr/>
-        </p:nvSpPr>
-        <p:spPr>
-          <a:xfrm>
-            <a:off x="5614416" y="4791456"/>
-            <a:ext cx="2377440" cy="365760"/>
-          </a:xfrm>
-          <a:prstGeom prst="rect">
-            <a:avLst/>
-          </a:prstGeom>
-          <a:solidFill>
-            <a:srgbClr val="EEF0F3"/>
-          </a:solidFill>
-          <a:ln/>
-        </p:spPr>
-        <p:txBody>
-          <a:bodyPr wrap="square" lIns="0" tIns="0" rIns="0" bIns="0" rtlCol="0" anchor="ctr"/>
-          <a:lstStyle/>
-          <a:p>
-            <a:pPr algn="ctr" indent="0" marL="0">
-              <a:buNone/>
-            </a:pPr>
-            <a:r>
-              <a:rPr lang="en-US" sz="950" b="1" dirty="0">
-                <a:solidFill>
-                  <a:schemeClr val="tx1"/>
-                </a:solidFill>
-              </a:rPr>
-              <a:t>그룹사 차세대 PI/ISP 수행 경험</a:t>
-            </a:r>
-            <a:endParaRPr lang="en-US" sz="950" dirty="0"/>
-          </a:p>
-        </p:txBody>
-      </p:sp>
-      <p:sp>
-        <p:nvSpPr>
-          <p:cNvPr id="43" name="Text 41"/>
-          <p:cNvSpPr txBox="1"/>
-          <p:nvPr/>
-        </p:nvSpPr>
-        <p:spPr>
-          <a:xfrm>
-            <a:off x="5614416" y="5212080"/>
-            <a:ext cx="2377440" cy="365760"/>
-          </a:xfrm>
-          <a:prstGeom prst="rect">
-            <a:avLst/>
-          </a:prstGeom>
-          <a:solidFill>
-            <a:srgbClr val="FFF9C4"/>
-          </a:solidFill>
-          <a:ln w="6350">
-            <a:solidFill>
-              <a:srgbClr val="D5D9E0"/>
-            </a:solidFill>
-          </a:ln>
-        </p:spPr>
-        <p:txBody>
-          <a:bodyPr wrap="square" lIns="0" tIns="0" rIns="0" bIns="0" rtlCol="0" anchor="ctr"/>
-          <a:lstStyle/>
-          <a:p>
-            <a:pPr algn="ctr" indent="0" marL="0">
-              <a:buNone/>
-            </a:pPr>
-            <a:r>
-              <a:rPr lang="en-US" sz="1000" b="1" dirty="0">
-                <a:solidFill>
-                  <a:schemeClr val="tx1"/>
-                </a:solidFill>
-              </a:rPr>
-              <a:t>도메인 전문성</a:t>
-            </a:r>
-            <a:endParaRPr lang="en-US" sz="1000" dirty="0"/>
-          </a:p>
-        </p:txBody>
-      </p:sp>
-      <p:sp>
-        <p:nvSpPr>
-          <p:cNvPr id="44" name="공동 TF 역할"/>
-          <p:cNvSpPr txBox="1"/>
-          <p:nvPr/>
-        </p:nvSpPr>
-        <p:spPr>
-          <a:xfrm>
-            <a:off x="3145536" y="5687568"/>
-            <a:ext cx="4855464" cy="457200"/>
-          </a:xfrm>
-          <a:prstGeom prst="rect">
-            <a:avLst/>
-          </a:prstGeom>
-          <a:solidFill>
-            <a:schemeClr val="tx2"/>
-          </a:solidFill>
-          <a:ln/>
-        </p:spPr>
-        <p:txBody>
-          <a:bodyPr wrap="square" lIns="0" tIns="0" rIns="0" bIns="0" rtlCol="0" anchor="ctr"/>
-          <a:lstStyle/>
-          <a:p>
-            <a:pPr algn="ctr" indent="0" marL="0">
-              <a:buNone/>
-            </a:pPr>
-            <a:r>
-              <a:rPr lang="en-US" sz="1050" b="1" dirty="0">
-                <a:solidFill>
-                  <a:schemeClr val="bg1"/>
-                </a:solidFill>
-              </a:rPr>
-              <a:t>FDE 공동 TF : 과제 Target 선정 → 적용 설계 → 성과 관리</a:t>
-            </a:r>
-            <a:endParaRPr lang="en-US" sz="1050" dirty="0"/>
-          </a:p>
-        </p:txBody>
-      </p:sp>
-      <p:sp>
-        <p:nvSpPr>
-          <p:cNvPr id="45" name="Text 43"/>
-          <p:cNvSpPr txBox="1"/>
-          <p:nvPr/>
-        </p:nvSpPr>
-        <p:spPr>
-          <a:xfrm>
-            <a:off x="8732520" y="3310128"/>
-            <a:ext cx="2971800" cy="274320"/>
-          </a:xfrm>
-          <a:prstGeom prst="rect">
-            <a:avLst/>
-          </a:prstGeom>
-          <a:noFill/>
-          <a:ln/>
-        </p:spPr>
-        <p:txBody>
-          <a:bodyPr wrap="square" lIns="0" tIns="0" rIns="0" bIns="0" rtlCol="0" anchor="ctr"/>
-          <a:lstStyle/>
-          <a:p>
-            <a:pPr algn="ctr" indent="0" marL="0">
-              <a:buNone/>
-            </a:pPr>
-            <a:r>
-              <a:rPr lang="en-US" sz="1100" b="1" dirty="0">
-                <a:solidFill>
-                  <a:schemeClr val="tx2"/>
-                </a:solidFill>
-              </a:rPr>
-              <a:t>그룹사 제공 서비스</a:t>
-            </a:r>
-            <a:endParaRPr lang="en-US" sz="1100" dirty="0"/>
-          </a:p>
-        </p:txBody>
-      </p:sp>
-      <p:sp>
-        <p:nvSpPr>
-          <p:cNvPr id="46" name="서비스 1"/>
-          <p:cNvSpPr/>
-          <p:nvPr/>
-        </p:nvSpPr>
-        <p:spPr>
-          <a:xfrm>
-            <a:off x="8823960" y="3657600"/>
-            <a:ext cx="2880360" cy="365760"/>
-          </a:xfrm>
-          <a:prstGeom prst="homePlate">
-            <a:avLst/>
-          </a:prstGeom>
-          <a:solidFill>
-            <a:srgbClr val="0F7B6C"/>
+            <a:srgbClr val="2E5C8A"/>
           </a:solidFill>
           <a:ln/>
           <a:effectLst>
@@ -2880,14 +2180,579 @@
               <a:buNone/>
             </a:pPr>
             <a:r>
-              <a:rPr lang="en-US" sz="1200" b="1" dirty="0">
-                <a:solidFill>
-                  <a:schemeClr val="bg1"/>
-                </a:solidFill>
-              </a:rPr>
-              <a:t>AX 진단 · 과제 발굴</a:t>
-            </a:r>
-            <a:endParaRPr lang="en-US" sz="1200" dirty="0"/>
+              <a:rPr lang="en-US" sz="1100" b="1" dirty="0">
+                <a:solidFill>
+                  <a:srgbClr val="FFFFFF"/>
+                </a:solidFill>
+              </a:rPr>
+              <a:t>MVP 구축 · 운영 이관</a:t>
+            </a:r>
+            <a:endParaRPr lang="en-US" sz="1100" dirty="0"/>
+          </a:p>
+        </p:txBody>
+      </p:sp>
+      <p:sp>
+        <p:nvSpPr>
+          <p:cNvPr id="27" name="점 0"/>
+          <p:cNvSpPr/>
+          <p:nvPr/>
+        </p:nvSpPr>
+        <p:spPr>
+          <a:xfrm>
+            <a:off x="2606040" y="4480560"/>
+            <a:ext cx="68580" cy="68580"/>
+          </a:xfrm>
+          <a:prstGeom prst="ellipse">
+            <a:avLst/>
+          </a:prstGeom>
+          <a:solidFill>
+            <a:srgbClr val="BFBFBF"/>
+          </a:solidFill>
+          <a:ln w="12700">
+            <a:solidFill>
+              <a:srgbClr val="BFBFBF"/>
+            </a:solidFill>
+            <a:prstDash val="solid"/>
+          </a:ln>
+        </p:spPr>
+      </p:sp>
+      <p:sp>
+        <p:nvSpPr>
+          <p:cNvPr id="28" name="점 1"/>
+          <p:cNvSpPr/>
+          <p:nvPr/>
+        </p:nvSpPr>
+        <p:spPr>
+          <a:xfrm>
+            <a:off x="2606040" y="4590288"/>
+            <a:ext cx="68580" cy="68580"/>
+          </a:xfrm>
+          <a:prstGeom prst="ellipse">
+            <a:avLst/>
+          </a:prstGeom>
+          <a:solidFill>
+            <a:srgbClr val="BFBFBF"/>
+          </a:solidFill>
+          <a:ln w="12700">
+            <a:solidFill>
+              <a:srgbClr val="BFBFBF"/>
+            </a:solidFill>
+            <a:prstDash val="solid"/>
+          </a:ln>
+        </p:spPr>
+      </p:sp>
+      <p:sp>
+        <p:nvSpPr>
+          <p:cNvPr id="29" name="점 2"/>
+          <p:cNvSpPr/>
+          <p:nvPr/>
+        </p:nvSpPr>
+        <p:spPr>
+          <a:xfrm>
+            <a:off x="2606040" y="4700016"/>
+            <a:ext cx="68580" cy="68580"/>
+          </a:xfrm>
+          <a:prstGeom prst="ellipse">
+            <a:avLst/>
+          </a:prstGeom>
+          <a:solidFill>
+            <a:srgbClr val="BFBFBF"/>
+          </a:solidFill>
+          <a:ln w="12700">
+            <a:solidFill>
+              <a:srgbClr val="BFBFBF"/>
+            </a:solidFill>
+            <a:prstDash val="solid"/>
+          </a:ln>
+        </p:spPr>
+      </p:sp>
+      <p:sp>
+        <p:nvSpPr>
+          <p:cNvPr id="30" name="점 3"/>
+          <p:cNvSpPr/>
+          <p:nvPr/>
+        </p:nvSpPr>
+        <p:spPr>
+          <a:xfrm>
+            <a:off x="2606040" y="4809744"/>
+            <a:ext cx="68580" cy="68580"/>
+          </a:xfrm>
+          <a:prstGeom prst="ellipse">
+            <a:avLst/>
+          </a:prstGeom>
+          <a:solidFill>
+            <a:srgbClr val="BFBFBF"/>
+          </a:solidFill>
+          <a:ln w="12700">
+            <a:solidFill>
+              <a:srgbClr val="BFBFBF"/>
+            </a:solidFill>
+            <a:prstDash val="solid"/>
+          </a:ln>
+        </p:spPr>
+      </p:sp>
+      <p:sp>
+        <p:nvSpPr>
+          <p:cNvPr id="31" name="점 4"/>
+          <p:cNvSpPr/>
+          <p:nvPr/>
+        </p:nvSpPr>
+        <p:spPr>
+          <a:xfrm>
+            <a:off x="2606040" y="4919472"/>
+            <a:ext cx="68580" cy="68580"/>
+          </a:xfrm>
+          <a:prstGeom prst="ellipse">
+            <a:avLst/>
+          </a:prstGeom>
+          <a:solidFill>
+            <a:srgbClr val="BFBFBF"/>
+          </a:solidFill>
+          <a:ln w="12700">
+            <a:solidFill>
+              <a:srgbClr val="BFBFBF"/>
+            </a:solidFill>
+            <a:prstDash val="solid"/>
+          </a:ln>
+        </p:spPr>
+      </p:sp>
+      <p:sp>
+        <p:nvSpPr>
+          <p:cNvPr id="32" name="점 5"/>
+          <p:cNvSpPr/>
+          <p:nvPr/>
+        </p:nvSpPr>
+        <p:spPr>
+          <a:xfrm>
+            <a:off x="2724912" y="4480560"/>
+            <a:ext cx="68580" cy="68580"/>
+          </a:xfrm>
+          <a:prstGeom prst="ellipse">
+            <a:avLst/>
+          </a:prstGeom>
+          <a:solidFill>
+            <a:srgbClr val="BFBFBF"/>
+          </a:solidFill>
+          <a:ln w="12700">
+            <a:solidFill>
+              <a:srgbClr val="BFBFBF"/>
+            </a:solidFill>
+            <a:prstDash val="solid"/>
+          </a:ln>
+        </p:spPr>
+      </p:sp>
+      <p:sp>
+        <p:nvSpPr>
+          <p:cNvPr id="33" name="점 6"/>
+          <p:cNvSpPr/>
+          <p:nvPr/>
+        </p:nvSpPr>
+        <p:spPr>
+          <a:xfrm>
+            <a:off x="2724912" y="4590288"/>
+            <a:ext cx="68580" cy="68580"/>
+          </a:xfrm>
+          <a:prstGeom prst="ellipse">
+            <a:avLst/>
+          </a:prstGeom>
+          <a:solidFill>
+            <a:srgbClr val="BFBFBF"/>
+          </a:solidFill>
+          <a:ln w="12700">
+            <a:solidFill>
+              <a:srgbClr val="BFBFBF"/>
+            </a:solidFill>
+            <a:prstDash val="solid"/>
+          </a:ln>
+        </p:spPr>
+      </p:sp>
+      <p:sp>
+        <p:nvSpPr>
+          <p:cNvPr id="34" name="점 7"/>
+          <p:cNvSpPr/>
+          <p:nvPr/>
+        </p:nvSpPr>
+        <p:spPr>
+          <a:xfrm>
+            <a:off x="2724912" y="4700016"/>
+            <a:ext cx="68580" cy="68580"/>
+          </a:xfrm>
+          <a:prstGeom prst="ellipse">
+            <a:avLst/>
+          </a:prstGeom>
+          <a:solidFill>
+            <a:srgbClr val="BFBFBF"/>
+          </a:solidFill>
+          <a:ln w="12700">
+            <a:solidFill>
+              <a:srgbClr val="BFBFBF"/>
+            </a:solidFill>
+            <a:prstDash val="solid"/>
+          </a:ln>
+        </p:spPr>
+      </p:sp>
+      <p:sp>
+        <p:nvSpPr>
+          <p:cNvPr id="35" name="점 8"/>
+          <p:cNvSpPr/>
+          <p:nvPr/>
+        </p:nvSpPr>
+        <p:spPr>
+          <a:xfrm>
+            <a:off x="2724912" y="4809744"/>
+            <a:ext cx="68580" cy="68580"/>
+          </a:xfrm>
+          <a:prstGeom prst="ellipse">
+            <a:avLst/>
+          </a:prstGeom>
+          <a:solidFill>
+            <a:srgbClr val="BFBFBF"/>
+          </a:solidFill>
+          <a:ln w="12700">
+            <a:solidFill>
+              <a:srgbClr val="BFBFBF"/>
+            </a:solidFill>
+            <a:prstDash val="solid"/>
+          </a:ln>
+        </p:spPr>
+      </p:sp>
+      <p:sp>
+        <p:nvSpPr>
+          <p:cNvPr id="36" name="점 9"/>
+          <p:cNvSpPr/>
+          <p:nvPr/>
+        </p:nvSpPr>
+        <p:spPr>
+          <a:xfrm>
+            <a:off x="2724912" y="4919472"/>
+            <a:ext cx="68580" cy="68580"/>
+          </a:xfrm>
+          <a:prstGeom prst="ellipse">
+            <a:avLst/>
+          </a:prstGeom>
+          <a:solidFill>
+            <a:srgbClr val="BFBFBF"/>
+          </a:solidFill>
+          <a:ln w="12700">
+            <a:solidFill>
+              <a:srgbClr val="BFBFBF"/>
+            </a:solidFill>
+            <a:prstDash val="solid"/>
+          </a:ln>
+        </p:spPr>
+      </p:sp>
+      <p:sp>
+        <p:nvSpPr>
+          <p:cNvPr id="37" name="점 10"/>
+          <p:cNvSpPr/>
+          <p:nvPr/>
+        </p:nvSpPr>
+        <p:spPr>
+          <a:xfrm>
+            <a:off x="2843784" y="4590288"/>
+            <a:ext cx="68580" cy="68580"/>
+          </a:xfrm>
+          <a:prstGeom prst="ellipse">
+            <a:avLst/>
+          </a:prstGeom>
+          <a:solidFill>
+            <a:srgbClr val="8C8C8C"/>
+          </a:solidFill>
+          <a:ln w="12700">
+            <a:solidFill>
+              <a:srgbClr val="8C8C8C"/>
+            </a:solidFill>
+            <a:prstDash val="solid"/>
+          </a:ln>
+        </p:spPr>
+      </p:sp>
+      <p:sp>
+        <p:nvSpPr>
+          <p:cNvPr id="38" name="점 11"/>
+          <p:cNvSpPr/>
+          <p:nvPr/>
+        </p:nvSpPr>
+        <p:spPr>
+          <a:xfrm>
+            <a:off x="2843784" y="4700016"/>
+            <a:ext cx="68580" cy="68580"/>
+          </a:xfrm>
+          <a:prstGeom prst="ellipse">
+            <a:avLst/>
+          </a:prstGeom>
+          <a:solidFill>
+            <a:srgbClr val="8C8C8C"/>
+          </a:solidFill>
+          <a:ln w="12700">
+            <a:solidFill>
+              <a:srgbClr val="8C8C8C"/>
+            </a:solidFill>
+            <a:prstDash val="solid"/>
+          </a:ln>
+        </p:spPr>
+      </p:sp>
+      <p:sp>
+        <p:nvSpPr>
+          <p:cNvPr id="39" name="점 12"/>
+          <p:cNvSpPr/>
+          <p:nvPr/>
+        </p:nvSpPr>
+        <p:spPr>
+          <a:xfrm>
+            <a:off x="2843784" y="4809744"/>
+            <a:ext cx="68580" cy="68580"/>
+          </a:xfrm>
+          <a:prstGeom prst="ellipse">
+            <a:avLst/>
+          </a:prstGeom>
+          <a:solidFill>
+            <a:srgbClr val="8C8C8C"/>
+          </a:solidFill>
+          <a:ln w="12700">
+            <a:solidFill>
+              <a:srgbClr val="8C8C8C"/>
+            </a:solidFill>
+            <a:prstDash val="solid"/>
+          </a:ln>
+        </p:spPr>
+      </p:sp>
+      <p:sp>
+        <p:nvSpPr>
+          <p:cNvPr id="40" name="점 13"/>
+          <p:cNvSpPr/>
+          <p:nvPr/>
+        </p:nvSpPr>
+        <p:spPr>
+          <a:xfrm>
+            <a:off x="2962656" y="4700016"/>
+            <a:ext cx="68580" cy="68580"/>
+          </a:xfrm>
+          <a:prstGeom prst="ellipse">
+            <a:avLst/>
+          </a:prstGeom>
+          <a:solidFill>
+            <a:srgbClr val="8C8C8C"/>
+          </a:solidFill>
+          <a:ln w="12700">
+            <a:solidFill>
+              <a:srgbClr val="8C8C8C"/>
+            </a:solidFill>
+            <a:prstDash val="solid"/>
+          </a:ln>
+        </p:spPr>
+      </p:sp>
+      <p:sp>
+        <p:nvSpPr>
+          <p:cNvPr id="41" name="Biz 그룹 박스"/>
+          <p:cNvSpPr/>
+          <p:nvPr/>
+        </p:nvSpPr>
+        <p:spPr>
+          <a:xfrm>
+            <a:off x="3035808" y="3310128"/>
+            <a:ext cx="5074920" cy="2944368"/>
+          </a:xfrm>
+          <a:prstGeom prst="roundRect">
+            <a:avLst>
+              <a:gd name="adj" fmla="val 2484"/>
+            </a:avLst>
+          </a:prstGeom>
+          <a:solidFill>
+            <a:srgbClr val="FFFFFF"/>
+          </a:solidFill>
+          <a:ln w="12700">
+            <a:solidFill>
+              <a:srgbClr val="D9D9D9"/>
+            </a:solidFill>
+            <a:prstDash val="solid"/>
+          </a:ln>
+        </p:spPr>
+      </p:sp>
+      <p:sp>
+        <p:nvSpPr>
+          <p:cNvPr id="42" name="Text 40"/>
+          <p:cNvSpPr txBox="1"/>
+          <p:nvPr/>
+        </p:nvSpPr>
+        <p:spPr>
+          <a:xfrm>
+            <a:off x="3035808" y="3346704"/>
+            <a:ext cx="5074920" cy="292608"/>
+          </a:xfrm>
+          <a:prstGeom prst="rect">
+            <a:avLst/>
+          </a:prstGeom>
+          <a:noFill/>
+          <a:ln/>
+        </p:spPr>
+        <p:txBody>
+          <a:bodyPr wrap="square" lIns="0" tIns="0" rIns="0" bIns="0" rtlCol="0" anchor="ctr"/>
+          <a:lstStyle/>
+          <a:p>
+            <a:pPr algn="ctr" indent="0" marL="0">
+              <a:buNone/>
+            </a:pPr>
+            <a:r>
+              <a:rPr lang="en-US" sz="1100" b="1" dirty="0">
+                <a:solidFill>
+                  <a:srgbClr val="595959"/>
+                </a:solidFill>
+              </a:rPr>
+              <a:t>Biz 그룹 (문제정의 · 적용설계)</a:t>
+            </a:r>
+            <a:endParaRPr lang="en-US" sz="1100" dirty="0"/>
+          </a:p>
+        </p:txBody>
+      </p:sp>
+      <p:sp>
+        <p:nvSpPr>
+          <p:cNvPr id="43" name="팀 AX컨설팅팀"/>
+          <p:cNvSpPr txBox="1"/>
+          <p:nvPr/>
+        </p:nvSpPr>
+        <p:spPr>
+          <a:xfrm>
+            <a:off x="3145536" y="3703320"/>
+            <a:ext cx="2377440" cy="310896"/>
+          </a:xfrm>
+          <a:prstGeom prst="rect">
+            <a:avLst/>
+          </a:prstGeom>
+          <a:solidFill>
+            <a:srgbClr val="2E5C8A"/>
+          </a:solidFill>
+          <a:ln/>
+        </p:spPr>
+        <p:txBody>
+          <a:bodyPr wrap="square" lIns="0" tIns="0" rIns="0" bIns="0" rtlCol="0" anchor="ctr"/>
+          <a:lstStyle/>
+          <a:p>
+            <a:pPr algn="ctr" indent="0" marL="0">
+              <a:buNone/>
+            </a:pPr>
+            <a:r>
+              <a:rPr lang="en-US" sz="1150" b="1" dirty="0">
+                <a:solidFill>
+                  <a:srgbClr val="FFFFFF"/>
+                </a:solidFill>
+              </a:rPr>
+              <a:t>AX컨설팅팀</a:t>
+            </a:r>
+            <a:endParaRPr lang="en-US" sz="1150" dirty="0"/>
+          </a:p>
+        </p:txBody>
+      </p:sp>
+      <p:sp>
+        <p:nvSpPr>
+          <p:cNvPr id="44" name="Text 42"/>
+          <p:cNvSpPr txBox="1"/>
+          <p:nvPr/>
+        </p:nvSpPr>
+        <p:spPr>
+          <a:xfrm>
+            <a:off x="3145536" y="4069080"/>
+            <a:ext cx="1161288" cy="301752"/>
+          </a:xfrm>
+          <a:prstGeom prst="rect">
+            <a:avLst/>
+          </a:prstGeom>
+          <a:solidFill>
+            <a:srgbClr val="A6A6A6"/>
+          </a:solidFill>
+          <a:ln/>
+        </p:spPr>
+        <p:txBody>
+          <a:bodyPr wrap="square" lIns="0" tIns="0" rIns="0" bIns="0" rtlCol="0" anchor="ctr"/>
+          <a:lstStyle/>
+          <a:p>
+            <a:pPr algn="ctr" indent="0" marL="0">
+              <a:buNone/>
+            </a:pPr>
+            <a:r>
+              <a:rPr lang="en-US" sz="950" b="1" dirty="0">
+                <a:solidFill>
+                  <a:srgbClr val="FFFFFF"/>
+                </a:solidFill>
+              </a:rPr>
+              <a:t>진단/발굴 9건</a:t>
+            </a:r>
+            <a:endParaRPr lang="en-US" sz="950" dirty="0"/>
+          </a:p>
+        </p:txBody>
+      </p:sp>
+      <p:sp>
+        <p:nvSpPr>
+          <p:cNvPr id="45" name="Text 43"/>
+          <p:cNvSpPr txBox="1"/>
+          <p:nvPr/>
+        </p:nvSpPr>
+        <p:spPr>
+          <a:xfrm>
+            <a:off x="4361688" y="4069080"/>
+            <a:ext cx="1161288" cy="301752"/>
+          </a:xfrm>
+          <a:prstGeom prst="rect">
+            <a:avLst/>
+          </a:prstGeom>
+          <a:solidFill>
+            <a:srgbClr val="A6A6A6"/>
+          </a:solidFill>
+          <a:ln/>
+        </p:spPr>
+        <p:txBody>
+          <a:bodyPr wrap="square" lIns="0" tIns="0" rIns="0" bIns="0" rtlCol="0" anchor="ctr"/>
+          <a:lstStyle/>
+          <a:p>
+            <a:pPr algn="ctr" indent="0" marL="0">
+              <a:buNone/>
+            </a:pPr>
+            <a:r>
+              <a:rPr lang="en-US" sz="950" b="1" dirty="0">
+                <a:solidFill>
+                  <a:srgbClr val="FFFFFF"/>
+                </a:solidFill>
+              </a:rPr>
+              <a:t>전략수립 4건</a:t>
+            </a:r>
+            <a:endParaRPr lang="en-US" sz="950" dirty="0"/>
+          </a:p>
+        </p:txBody>
+      </p:sp>
+      <p:sp>
+        <p:nvSpPr>
+          <p:cNvPr id="46" name="Text 44"/>
+          <p:cNvSpPr txBox="1"/>
+          <p:nvPr/>
+        </p:nvSpPr>
+        <p:spPr>
+          <a:xfrm>
+            <a:off x="3145536" y="4407408"/>
+            <a:ext cx="1161288" cy="301752"/>
+          </a:xfrm>
+          <a:prstGeom prst="rect">
+            <a:avLst/>
+          </a:prstGeom>
+          <a:solidFill>
+            <a:srgbClr val="A6A6A6"/>
+          </a:solidFill>
+          <a:ln/>
+        </p:spPr>
+        <p:txBody>
+          <a:bodyPr wrap="square" lIns="0" tIns="0" rIns="0" bIns="0" rtlCol="0" anchor="ctr"/>
+          <a:lstStyle/>
+          <a:p>
+            <a:pPr algn="ctr" indent="0" marL="0">
+              <a:buNone/>
+            </a:pPr>
+            <a:r>
+              <a:rPr lang="en-US" sz="950" b="1" dirty="0">
+                <a:solidFill>
+                  <a:srgbClr val="FFFFFF"/>
+                </a:solidFill>
+              </a:rPr>
+              <a:t>특화영역 3건</a:t>
+            </a:r>
+            <a:endParaRPr lang="en-US" sz="950" dirty="0"/>
           </a:p>
         </p:txBody>
       </p:sp>
@@ -2899,8 +2764,426 @@
         </p:nvSpPr>
         <p:spPr>
           <a:xfrm>
-            <a:off x="8915400" y="4041648"/>
-            <a:ext cx="2834640" cy="420624"/>
+            <a:off x="4361688" y="4407408"/>
+            <a:ext cx="1161288" cy="301752"/>
+          </a:xfrm>
+          <a:prstGeom prst="rect">
+            <a:avLst/>
+          </a:prstGeom>
+          <a:solidFill>
+            <a:srgbClr val="A6A6A6"/>
+          </a:solidFill>
+          <a:ln/>
+        </p:spPr>
+        <p:txBody>
+          <a:bodyPr wrap="square" lIns="0" tIns="0" rIns="0" bIns="0" rtlCol="0" anchor="ctr"/>
+          <a:lstStyle/>
+          <a:p>
+            <a:pPr algn="ctr" indent="0" marL="0">
+              <a:buNone/>
+            </a:pPr>
+            <a:r>
+              <a:rPr lang="en-US" sz="950" b="1" dirty="0">
+                <a:solidFill>
+                  <a:srgbClr val="FFFFFF"/>
+                </a:solidFill>
+              </a:rPr>
+              <a:t>AX교육 6건</a:t>
+            </a:r>
+            <a:endParaRPr lang="en-US" sz="950" dirty="0"/>
+          </a:p>
+        </p:txBody>
+      </p:sp>
+      <p:sp>
+        <p:nvSpPr>
+          <p:cNvPr id="48" name="Text 46"/>
+          <p:cNvSpPr txBox="1"/>
+          <p:nvPr/>
+        </p:nvSpPr>
+        <p:spPr>
+          <a:xfrm>
+            <a:off x="3145536" y="4791456"/>
+            <a:ext cx="2377440" cy="365760"/>
+          </a:xfrm>
+          <a:prstGeom prst="rect">
+            <a:avLst/>
+          </a:prstGeom>
+          <a:solidFill>
+            <a:srgbClr val="D9D9D9"/>
+          </a:solidFill>
+          <a:ln/>
+        </p:spPr>
+        <p:txBody>
+          <a:bodyPr wrap="square" lIns="0" tIns="0" rIns="0" bIns="0" rtlCol="0" anchor="ctr"/>
+          <a:lstStyle/>
+          <a:p>
+            <a:pPr algn="ctr" indent="0" marL="0">
+              <a:buNone/>
+            </a:pPr>
+            <a:r>
+              <a:rPr lang="en-US" sz="950" b="1" dirty="0">
+                <a:solidFill>
+                  <a:srgbClr val="262626"/>
+                </a:solidFill>
+              </a:rPr>
+              <a:t>그룹사 AI컨설팅 수행 경험</a:t>
+            </a:r>
+            <a:endParaRPr lang="en-US" sz="950" dirty="0"/>
+          </a:p>
+        </p:txBody>
+      </p:sp>
+      <p:sp>
+        <p:nvSpPr>
+          <p:cNvPr id="49" name="Text 47"/>
+          <p:cNvSpPr txBox="1"/>
+          <p:nvPr/>
+        </p:nvSpPr>
+        <p:spPr>
+          <a:xfrm>
+            <a:off x="3145536" y="5212080"/>
+            <a:ext cx="2377440" cy="365760"/>
+          </a:xfrm>
+          <a:prstGeom prst="rect">
+            <a:avLst/>
+          </a:prstGeom>
+          <a:solidFill>
+            <a:srgbClr val="2E5C8A"/>
+          </a:solidFill>
+          <a:ln/>
+        </p:spPr>
+        <p:txBody>
+          <a:bodyPr wrap="square" lIns="0" tIns="0" rIns="0" bIns="0" rtlCol="0" anchor="ctr"/>
+          <a:lstStyle/>
+          <a:p>
+            <a:pPr algn="ctr" indent="0" marL="0">
+              <a:buNone/>
+            </a:pPr>
+            <a:r>
+              <a:rPr lang="en-US" sz="1000" b="1" dirty="0">
+                <a:solidFill>
+                  <a:srgbClr val="FFFFFF"/>
+                </a:solidFill>
+              </a:rPr>
+              <a:t>AI추진과제 Pool 108건</a:t>
+            </a:r>
+            <a:endParaRPr lang="en-US" sz="1000" dirty="0"/>
+          </a:p>
+        </p:txBody>
+      </p:sp>
+      <p:sp>
+        <p:nvSpPr>
+          <p:cNvPr id="50" name="팀 Biz컨설팅팀"/>
+          <p:cNvSpPr txBox="1"/>
+          <p:nvPr/>
+        </p:nvSpPr>
+        <p:spPr>
+          <a:xfrm>
+            <a:off x="5614416" y="3703320"/>
+            <a:ext cx="2377440" cy="310896"/>
+          </a:xfrm>
+          <a:prstGeom prst="rect">
+            <a:avLst/>
+          </a:prstGeom>
+          <a:solidFill>
+            <a:srgbClr val="404040"/>
+          </a:solidFill>
+          <a:ln/>
+        </p:spPr>
+        <p:txBody>
+          <a:bodyPr wrap="square" lIns="0" tIns="0" rIns="0" bIns="0" rtlCol="0" anchor="ctr"/>
+          <a:lstStyle/>
+          <a:p>
+            <a:pPr algn="ctr" indent="0" marL="0">
+              <a:buNone/>
+            </a:pPr>
+            <a:r>
+              <a:rPr lang="en-US" sz="1150" b="1" dirty="0">
+                <a:solidFill>
+                  <a:srgbClr val="FFFFFF"/>
+                </a:solidFill>
+              </a:rPr>
+              <a:t>Biz컨설팅팀</a:t>
+            </a:r>
+            <a:endParaRPr lang="en-US" sz="1150" dirty="0"/>
+          </a:p>
+        </p:txBody>
+      </p:sp>
+      <p:sp>
+        <p:nvSpPr>
+          <p:cNvPr id="51" name="Text 49"/>
+          <p:cNvSpPr txBox="1"/>
+          <p:nvPr/>
+        </p:nvSpPr>
+        <p:spPr>
+          <a:xfrm>
+            <a:off x="5614416" y="4069080"/>
+            <a:ext cx="1161288" cy="301752"/>
+          </a:xfrm>
+          <a:prstGeom prst="rect">
+            <a:avLst/>
+          </a:prstGeom>
+          <a:solidFill>
+            <a:srgbClr val="595959"/>
+          </a:solidFill>
+          <a:ln/>
+        </p:spPr>
+        <p:txBody>
+          <a:bodyPr wrap="square" lIns="0" tIns="0" rIns="0" bIns="0" rtlCol="0" anchor="ctr"/>
+          <a:lstStyle/>
+          <a:p>
+            <a:pPr algn="ctr" indent="0" marL="0">
+              <a:buNone/>
+            </a:pPr>
+            <a:r>
+              <a:rPr lang="en-US" sz="950" b="1" dirty="0">
+                <a:solidFill>
+                  <a:srgbClr val="FFFFFF"/>
+                </a:solidFill>
+              </a:rPr>
+              <a:t>식품/제조</a:t>
+            </a:r>
+            <a:endParaRPr lang="en-US" sz="950" dirty="0"/>
+          </a:p>
+        </p:txBody>
+      </p:sp>
+      <p:sp>
+        <p:nvSpPr>
+          <p:cNvPr id="52" name="Text 50"/>
+          <p:cNvSpPr txBox="1"/>
+          <p:nvPr/>
+        </p:nvSpPr>
+        <p:spPr>
+          <a:xfrm>
+            <a:off x="6830568" y="4069080"/>
+            <a:ext cx="1161288" cy="301752"/>
+          </a:xfrm>
+          <a:prstGeom prst="rect">
+            <a:avLst/>
+          </a:prstGeom>
+          <a:solidFill>
+            <a:srgbClr val="595959"/>
+          </a:solidFill>
+          <a:ln/>
+        </p:spPr>
+        <p:txBody>
+          <a:bodyPr wrap="square" lIns="0" tIns="0" rIns="0" bIns="0" rtlCol="0" anchor="ctr"/>
+          <a:lstStyle/>
+          <a:p>
+            <a:pPr algn="ctr" indent="0" marL="0">
+              <a:buNone/>
+            </a:pPr>
+            <a:r>
+              <a:rPr lang="en-US" sz="950" b="1" dirty="0">
+                <a:solidFill>
+                  <a:srgbClr val="FFFFFF"/>
+                </a:solidFill>
+              </a:rPr>
+              <a:t>유통</a:t>
+            </a:r>
+            <a:endParaRPr lang="en-US" sz="950" dirty="0"/>
+          </a:p>
+        </p:txBody>
+      </p:sp>
+      <p:sp>
+        <p:nvSpPr>
+          <p:cNvPr id="53" name="Text 51"/>
+          <p:cNvSpPr txBox="1"/>
+          <p:nvPr/>
+        </p:nvSpPr>
+        <p:spPr>
+          <a:xfrm>
+            <a:off x="5614416" y="4407408"/>
+            <a:ext cx="1161288" cy="301752"/>
+          </a:xfrm>
+          <a:prstGeom prst="rect">
+            <a:avLst/>
+          </a:prstGeom>
+          <a:solidFill>
+            <a:srgbClr val="595959"/>
+          </a:solidFill>
+          <a:ln/>
+        </p:spPr>
+        <p:txBody>
+          <a:bodyPr wrap="square" lIns="0" tIns="0" rIns="0" bIns="0" rtlCol="0" anchor="ctr"/>
+          <a:lstStyle/>
+          <a:p>
+            <a:pPr algn="ctr" indent="0" marL="0">
+              <a:buNone/>
+            </a:pPr>
+            <a:r>
+              <a:rPr lang="en-US" sz="950" b="1" dirty="0">
+                <a:solidFill>
+                  <a:srgbClr val="FFFFFF"/>
+                </a:solidFill>
+              </a:rPr>
+              <a:t>화학/건설</a:t>
+            </a:r>
+            <a:endParaRPr lang="en-US" sz="950" dirty="0"/>
+          </a:p>
+        </p:txBody>
+      </p:sp>
+      <p:sp>
+        <p:nvSpPr>
+          <p:cNvPr id="54" name="Text 52"/>
+          <p:cNvSpPr txBox="1"/>
+          <p:nvPr/>
+        </p:nvSpPr>
+        <p:spPr>
+          <a:xfrm>
+            <a:off x="6830568" y="4407408"/>
+            <a:ext cx="1161288" cy="301752"/>
+          </a:xfrm>
+          <a:prstGeom prst="rect">
+            <a:avLst/>
+          </a:prstGeom>
+          <a:solidFill>
+            <a:srgbClr val="595959"/>
+          </a:solidFill>
+          <a:ln/>
+        </p:spPr>
+        <p:txBody>
+          <a:bodyPr wrap="square" lIns="0" tIns="0" rIns="0" bIns="0" rtlCol="0" anchor="ctr"/>
+          <a:lstStyle/>
+          <a:p>
+            <a:pPr algn="ctr" indent="0" marL="0">
+              <a:buNone/>
+            </a:pPr>
+            <a:r>
+              <a:rPr lang="en-US" sz="950" b="1" dirty="0">
+                <a:solidFill>
+                  <a:srgbClr val="FFFFFF"/>
+                </a:solidFill>
+              </a:rPr>
+              <a:t>호텔/서비스</a:t>
+            </a:r>
+            <a:endParaRPr lang="en-US" sz="950" dirty="0"/>
+          </a:p>
+        </p:txBody>
+      </p:sp>
+      <p:sp>
+        <p:nvSpPr>
+          <p:cNvPr id="55" name="Text 53"/>
+          <p:cNvSpPr txBox="1"/>
+          <p:nvPr/>
+        </p:nvSpPr>
+        <p:spPr>
+          <a:xfrm>
+            <a:off x="5614416" y="4791456"/>
+            <a:ext cx="2377440" cy="365760"/>
+          </a:xfrm>
+          <a:prstGeom prst="rect">
+            <a:avLst/>
+          </a:prstGeom>
+          <a:solidFill>
+            <a:srgbClr val="D9D9D9"/>
+          </a:solidFill>
+          <a:ln/>
+        </p:spPr>
+        <p:txBody>
+          <a:bodyPr wrap="square" lIns="0" tIns="0" rIns="0" bIns="0" rtlCol="0" anchor="ctr"/>
+          <a:lstStyle/>
+          <a:p>
+            <a:pPr algn="ctr" indent="0" marL="0">
+              <a:buNone/>
+            </a:pPr>
+            <a:r>
+              <a:rPr lang="en-US" sz="950" b="1" dirty="0">
+                <a:solidFill>
+                  <a:srgbClr val="262626"/>
+                </a:solidFill>
+              </a:rPr>
+              <a:t>그룹사 차세대 PI/ISP 수행 경험</a:t>
+            </a:r>
+            <a:endParaRPr lang="en-US" sz="950" dirty="0"/>
+          </a:p>
+        </p:txBody>
+      </p:sp>
+      <p:sp>
+        <p:nvSpPr>
+          <p:cNvPr id="56" name="Text 54"/>
+          <p:cNvSpPr txBox="1"/>
+          <p:nvPr/>
+        </p:nvSpPr>
+        <p:spPr>
+          <a:xfrm>
+            <a:off x="5614416" y="5212080"/>
+            <a:ext cx="2377440" cy="365760"/>
+          </a:xfrm>
+          <a:prstGeom prst="rect">
+            <a:avLst/>
+          </a:prstGeom>
+          <a:solidFill>
+            <a:srgbClr val="2E5C8A"/>
+          </a:solidFill>
+          <a:ln/>
+        </p:spPr>
+        <p:txBody>
+          <a:bodyPr wrap="square" lIns="0" tIns="0" rIns="0" bIns="0" rtlCol="0" anchor="ctr"/>
+          <a:lstStyle/>
+          <a:p>
+            <a:pPr algn="ctr" indent="0" marL="0">
+              <a:buNone/>
+            </a:pPr>
+            <a:r>
+              <a:rPr lang="en-US" sz="1000" b="1" dirty="0">
+                <a:solidFill>
+                  <a:srgbClr val="FFFFFF"/>
+                </a:solidFill>
+              </a:rPr>
+              <a:t>도메인 전문성</a:t>
+            </a:r>
+            <a:endParaRPr lang="en-US" sz="1000" dirty="0"/>
+          </a:p>
+        </p:txBody>
+      </p:sp>
+      <p:sp>
+        <p:nvSpPr>
+          <p:cNvPr id="57" name="공동 TF 역할"/>
+          <p:cNvSpPr txBox="1"/>
+          <p:nvPr/>
+        </p:nvSpPr>
+        <p:spPr>
+          <a:xfrm>
+            <a:off x="3145536" y="5687568"/>
+            <a:ext cx="4855464" cy="457200"/>
+          </a:xfrm>
+          <a:prstGeom prst="rect">
+            <a:avLst/>
+          </a:prstGeom>
+          <a:solidFill>
+            <a:srgbClr val="404040"/>
+          </a:solidFill>
+          <a:ln/>
+        </p:spPr>
+        <p:txBody>
+          <a:bodyPr wrap="square" lIns="0" tIns="0" rIns="0" bIns="0" rtlCol="0" anchor="ctr"/>
+          <a:lstStyle/>
+          <a:p>
+            <a:pPr algn="ctr" indent="0" marL="0">
+              <a:buNone/>
+            </a:pPr>
+            <a:r>
+              <a:rPr lang="en-US" sz="1050" b="1" dirty="0">
+                <a:solidFill>
+                  <a:srgbClr val="FFFFFF"/>
+                </a:solidFill>
+              </a:rPr>
+              <a:t>FDE 공동 TF : 과제 Target 선정 → 적용 설계 → 성과 관리</a:t>
+            </a:r>
+            <a:endParaRPr lang="en-US" sz="1050" dirty="0"/>
+          </a:p>
+        </p:txBody>
+      </p:sp>
+      <p:sp>
+        <p:nvSpPr>
+          <p:cNvPr id="58" name="Text 56"/>
+          <p:cNvSpPr txBox="1"/>
+          <p:nvPr/>
+        </p:nvSpPr>
+        <p:spPr>
+          <a:xfrm>
+            <a:off x="8732520" y="3310128"/>
+            <a:ext cx="2971800" cy="274320"/>
           </a:xfrm>
           <a:prstGeom prst="rect">
             <a:avLst/>
@@ -2909,78 +3192,40 @@
           <a:ln/>
         </p:spPr>
         <p:txBody>
-          <a:bodyPr wrap="square" lIns="0" tIns="0" rIns="0" bIns="0" rtlCol="0" anchor="t"/>
-          <a:lstStyle/>
-          <a:p>
-            <a:pPr indent="0" marL="0">
-              <a:buNone/>
-            </a:pPr>
-            <a:r>
-              <a:rPr lang="en-US" sz="950" b="1" dirty="0">
-                <a:solidFill>
-                  <a:schemeClr val="tx1"/>
-                </a:solidFill>
-              </a:rPr>
-              <a:t>· Value Chain별 AI과제 진단·Target 선정</a:t>
-            </a:r>
-            <a:endParaRPr lang="en-US" sz="950" dirty="0"/>
-          </a:p>
-          <a:p>
-            <a:pPr indent="0" marL="0">
-              <a:buNone/>
-            </a:pPr>
-            <a:r>
-              <a:rPr lang="en-US" sz="950" b="1" dirty="0">
-                <a:solidFill>
-                  <a:schemeClr val="tx1"/>
-                </a:solidFill>
-              </a:rPr>
-              <a:t>· AX CAMP 현업 실습·과제 도출</a:t>
-            </a:r>
-            <a:endParaRPr lang="en-US" sz="950" dirty="0"/>
-          </a:p>
-        </p:txBody>
-      </p:sp>
-      <p:sp>
-        <p:nvSpPr>
-          <p:cNvPr id="48" name="연결 1"/>
+          <a:bodyPr wrap="square" lIns="0" tIns="0" rIns="0" bIns="0" rtlCol="0" anchor="ctr"/>
+          <a:lstStyle/>
+          <a:p>
+            <a:pPr algn="ctr" indent="0" marL="0">
+              <a:buNone/>
+            </a:pPr>
+            <a:r>
+              <a:rPr lang="en-US" sz="1100" b="1" dirty="0">
+                <a:solidFill>
+                  <a:srgbClr val="595959"/>
+                </a:solidFill>
+              </a:rPr>
+              <a:t>그룹사 제공 서비스</a:t>
+            </a:r>
+            <a:endParaRPr lang="en-US" sz="1100" dirty="0"/>
+          </a:p>
+        </p:txBody>
+      </p:sp>
+      <p:sp>
+        <p:nvSpPr>
+          <p:cNvPr id="59" name="서비스 1"/>
           <p:cNvSpPr/>
           <p:nvPr/>
         </p:nvSpPr>
         <p:spPr>
-          <a:xfrm flipV="1">
-            <a:off x="8110728" y="3840480"/>
-            <a:ext cx="685800" cy="960120"/>
-          </a:xfrm>
-          <a:prstGeom prst="line">
-            <a:avLst/>
-          </a:prstGeom>
-          <a:noFill/>
-          <a:ln w="28575">
-            <a:solidFill>
-              <a:srgbClr val="0F7B6C"/>
-            </a:solidFill>
-            <a:prstDash val="solid"/>
-            <a:tailEnd type="triangle"/>
-          </a:ln>
-        </p:spPr>
-      </p:sp>
-      <p:sp>
-        <p:nvSpPr>
-          <p:cNvPr id="49" name="서비스 2"/>
-          <p:cNvSpPr/>
-          <p:nvPr/>
-        </p:nvSpPr>
-        <p:spPr>
-          <a:xfrm>
-            <a:off x="8823960" y="4553712"/>
+          <a:xfrm>
+            <a:off x="8823960" y="3657600"/>
             <a:ext cx="2880360" cy="365760"/>
           </a:xfrm>
           <a:prstGeom prst="homePlate">
             <a:avLst/>
           </a:prstGeom>
           <a:solidFill>
-            <a:srgbClr val="1F4E9A"/>
+            <a:srgbClr val="A6A6A6"/>
           </a:solidFill>
           <a:ln/>
           <a:effectLst>
@@ -3004,7 +3249,7 @@
                   <a:schemeClr val="bg1"/>
                 </a:solidFill>
               </a:rPr>
-              <a:t>MVP 구축 · 검증</a:t>
+              <a:t>AX 진단 · 과제 발굴</a:t>
             </a:r>
             <a:endParaRPr lang="en-US" sz="1200" dirty="0"/>
           </a:p>
@@ -3012,13 +3257,13 @@
       </p:sp>
       <p:sp>
         <p:nvSpPr>
-          <p:cNvPr id="50" name="Text 48"/>
+          <p:cNvPr id="60" name="Text 58"/>
           <p:cNvSpPr txBox="1"/>
           <p:nvPr/>
         </p:nvSpPr>
         <p:spPr>
           <a:xfrm>
-            <a:off x="8915400" y="4937760"/>
+            <a:off x="8915400" y="4041648"/>
             <a:ext cx="2834640" cy="420624"/>
           </a:xfrm>
           <a:prstGeom prst="rect">
@@ -3037,10 +3282,10 @@
             <a:r>
               <a:rPr lang="en-US" sz="950" b="1" dirty="0">
                 <a:solidFill>
-                  <a:schemeClr val="tx1"/>
-                </a:solidFill>
-              </a:rPr>
-              <a:t>· 기간계 적용방안 + 6~8주 MVP</a:t>
+                  <a:srgbClr val="262626"/>
+                </a:solidFill>
+              </a:rPr>
+              <a:t>· Value Chain별 AI과제 진단·Target 선정</a:t>
             </a:r>
             <a:endParaRPr lang="en-US" sz="950" dirty="0"/>
           </a:p>
@@ -3051,10 +3296,10 @@
             <a:r>
               <a:rPr lang="en-US" sz="950" b="1" dirty="0">
                 <a:solidFill>
-                  <a:schemeClr val="tx1"/>
-                </a:solidFill>
-              </a:rPr>
-              <a:t>· 현업 검증·성과 측정 (Go/No-go)</a:t>
+                  <a:srgbClr val="262626"/>
+                </a:solidFill>
+              </a:rPr>
+              <a:t>· AX CAMP 현업 실습·과제 도출</a:t>
             </a:r>
             <a:endParaRPr lang="en-US" sz="950" dirty="0"/>
           </a:p>
@@ -3062,14 +3307,14 @@
       </p:sp>
       <p:sp>
         <p:nvSpPr>
-          <p:cNvPr id="51" name="연결 2"/>
+          <p:cNvPr id="61" name="연결 1"/>
           <p:cNvSpPr/>
           <p:nvPr/>
         </p:nvSpPr>
         <p:spPr>
           <a:xfrm flipV="1">
-            <a:off x="8110728" y="4736592"/>
-            <a:ext cx="685800" cy="64008"/>
+            <a:off x="8110728" y="3840480"/>
+            <a:ext cx="685800" cy="960120"/>
           </a:xfrm>
           <a:prstGeom prst="line">
             <a:avLst/>
@@ -3077,7 +3322,7 @@
           <a:noFill/>
           <a:ln w="28575">
             <a:solidFill>
-              <a:srgbClr val="1F4E9A"/>
+              <a:srgbClr val="A6A6A6"/>
             </a:solidFill>
             <a:prstDash val="solid"/>
             <a:tailEnd type="triangle"/>
@@ -3086,20 +3331,20 @@
       </p:sp>
       <p:sp>
         <p:nvSpPr>
-          <p:cNvPr id="52" name="서비스 3"/>
+          <p:cNvPr id="62" name="서비스 2"/>
           <p:cNvSpPr/>
           <p:nvPr/>
         </p:nvSpPr>
         <p:spPr>
           <a:xfrm>
-            <a:off x="8823960" y="5449824"/>
+            <a:off x="8823960" y="4553712"/>
             <a:ext cx="2880360" cy="365760"/>
           </a:xfrm>
           <a:prstGeom prst="homePlate">
             <a:avLst/>
           </a:prstGeom>
           <a:solidFill>
-            <a:srgbClr val="D0342C"/>
+            <a:srgbClr val="4A79A8"/>
           </a:solidFill>
           <a:ln/>
           <a:effectLst>
@@ -3123,7 +3368,7 @@
                   <a:schemeClr val="bg1"/>
                 </a:solidFill>
               </a:rPr>
-              <a:t>구축 · 운영 이관</a:t>
+              <a:t>MVP 구축 · 검증</a:t>
             </a:r>
             <a:endParaRPr lang="en-US" sz="1200" dirty="0"/>
           </a:p>
@@ -3131,13 +3376,13 @@
       </p:sp>
       <p:sp>
         <p:nvSpPr>
-          <p:cNvPr id="53" name="Text 51"/>
+          <p:cNvPr id="63" name="Text 61"/>
           <p:cNvSpPr txBox="1"/>
           <p:nvPr/>
         </p:nvSpPr>
         <p:spPr>
           <a:xfrm>
-            <a:off x="8915400" y="5833872"/>
+            <a:off x="8915400" y="4937760"/>
             <a:ext cx="2834640" cy="420624"/>
           </a:xfrm>
           <a:prstGeom prst="rect">
@@ -3156,10 +3401,10 @@
             <a:r>
               <a:rPr lang="en-US" sz="950" b="1" dirty="0">
                 <a:solidFill>
-                  <a:schemeClr val="tx1"/>
-                </a:solidFill>
-              </a:rPr>
-              <a:t>· 구축사업화 (엔지니어 협업)</a:t>
+                  <a:srgbClr val="262626"/>
+                </a:solidFill>
+              </a:rPr>
+              <a:t>· 기간계 적용방안 + 6~8주 MVP</a:t>
             </a:r>
             <a:endParaRPr lang="en-US" sz="950" dirty="0"/>
           </a:p>
@@ -3170,10 +3415,10 @@
             <a:r>
               <a:rPr lang="en-US" sz="950" b="1" dirty="0">
                 <a:solidFill>
-                  <a:schemeClr val="tx1"/>
-                </a:solidFill>
-              </a:rPr>
-              <a:t>· 운영 이관 · 그룹사 확산</a:t>
+                  <a:srgbClr val="262626"/>
+                </a:solidFill>
+              </a:rPr>
+              <a:t>· 현업 검증·성과 측정 (Go/No-go)</a:t>
             </a:r>
             <a:endParaRPr lang="en-US" sz="950" dirty="0"/>
           </a:p>
@@ -3181,14 +3426,14 @@
       </p:sp>
       <p:sp>
         <p:nvSpPr>
-          <p:cNvPr id="54" name="연결 3"/>
+          <p:cNvPr id="64" name="연결 2"/>
           <p:cNvSpPr/>
           <p:nvPr/>
         </p:nvSpPr>
         <p:spPr>
-          <a:xfrm>
-            <a:off x="8110728" y="4800600"/>
-            <a:ext cx="685800" cy="832104"/>
+          <a:xfrm flipV="1">
+            <a:off x="8110728" y="4736592"/>
+            <a:ext cx="685800" cy="64008"/>
           </a:xfrm>
           <a:prstGeom prst="line">
             <a:avLst/>
@@ -3196,7 +3441,126 @@
           <a:noFill/>
           <a:ln w="28575">
             <a:solidFill>
-              <a:srgbClr val="D0342C"/>
+              <a:srgbClr val="4A79A8"/>
+            </a:solidFill>
+            <a:prstDash val="solid"/>
+            <a:tailEnd type="triangle"/>
+          </a:ln>
+        </p:spPr>
+      </p:sp>
+      <p:sp>
+        <p:nvSpPr>
+          <p:cNvPr id="65" name="서비스 3"/>
+          <p:cNvSpPr/>
+          <p:nvPr/>
+        </p:nvSpPr>
+        <p:spPr>
+          <a:xfrm>
+            <a:off x="8823960" y="5449824"/>
+            <a:ext cx="2880360" cy="365760"/>
+          </a:xfrm>
+          <a:prstGeom prst="homePlate">
+            <a:avLst/>
+          </a:prstGeom>
+          <a:solidFill>
+            <a:srgbClr val="2E5C8A"/>
+          </a:solidFill>
+          <a:ln/>
+          <a:effectLst>
+            <a:outerShdw sx="100000" sy="100000" kx="0" ky="0" algn="bl" rotWithShape="0" blurRad="25400" dist="19050" dir="5400000">
+              <a:srgbClr val="999999">
+                <a:alpha val="40000"/>
+              </a:srgbClr>
+            </a:outerShdw>
+          </a:effectLst>
+        </p:spPr>
+        <p:txBody>
+          <a:bodyPr wrap="square" lIns="0" tIns="0" rIns="0" bIns="0" rtlCol="0" anchor="ctr"/>
+          <a:lstStyle/>
+          <a:p>
+            <a:pPr algn="ctr" indent="0" marL="0">
+              <a:buNone/>
+            </a:pPr>
+            <a:r>
+              <a:rPr lang="en-US" sz="1200" b="1" dirty="0">
+                <a:solidFill>
+                  <a:schemeClr val="bg1"/>
+                </a:solidFill>
+              </a:rPr>
+              <a:t>구축 · 운영 이관</a:t>
+            </a:r>
+            <a:endParaRPr lang="en-US" sz="1200" dirty="0"/>
+          </a:p>
+        </p:txBody>
+      </p:sp>
+      <p:sp>
+        <p:nvSpPr>
+          <p:cNvPr id="66" name="Text 64"/>
+          <p:cNvSpPr txBox="1"/>
+          <p:nvPr/>
+        </p:nvSpPr>
+        <p:spPr>
+          <a:xfrm>
+            <a:off x="8915400" y="5833872"/>
+            <a:ext cx="2834640" cy="420624"/>
+          </a:xfrm>
+          <a:prstGeom prst="rect">
+            <a:avLst/>
+          </a:prstGeom>
+          <a:noFill/>
+          <a:ln/>
+        </p:spPr>
+        <p:txBody>
+          <a:bodyPr wrap="square" lIns="0" tIns="0" rIns="0" bIns="0" rtlCol="0" anchor="t"/>
+          <a:lstStyle/>
+          <a:p>
+            <a:pPr indent="0" marL="0">
+              <a:buNone/>
+            </a:pPr>
+            <a:r>
+              <a:rPr lang="en-US" sz="950" b="1" dirty="0">
+                <a:solidFill>
+                  <a:srgbClr val="262626"/>
+                </a:solidFill>
+              </a:rPr>
+              <a:t>· 구축사업화 (엔지니어 협업)</a:t>
+            </a:r>
+            <a:endParaRPr lang="en-US" sz="950" dirty="0"/>
+          </a:p>
+          <a:p>
+            <a:pPr indent="0" marL="0">
+              <a:buNone/>
+            </a:pPr>
+            <a:r>
+              <a:rPr lang="en-US" sz="950" b="1" dirty="0">
+                <a:solidFill>
+                  <a:srgbClr val="262626"/>
+                </a:solidFill>
+              </a:rPr>
+              <a:t>· 운영 이관 · 그룹사 확산</a:t>
+            </a:r>
+            <a:endParaRPr lang="en-US" sz="950" dirty="0"/>
+          </a:p>
+        </p:txBody>
+      </p:sp>
+      <p:sp>
+        <p:nvSpPr>
+          <p:cNvPr id="67" name="연결 3"/>
+          <p:cNvSpPr/>
+          <p:nvPr/>
+        </p:nvSpPr>
+        <p:spPr>
+          <a:xfrm>
+            <a:off x="8110728" y="4800600"/>
+            <a:ext cx="685800" cy="832104"/>
+          </a:xfrm>
+          <a:prstGeom prst="line">
+            <a:avLst/>
+          </a:prstGeom>
+          <a:noFill/>
+          <a:ln w="28575">
+            <a:solidFill>
+              <a:srgbClr val="2E5C8A"/>
             </a:solidFill>
             <a:prstDash val="solid"/>
             <a:tailEnd type="triangle"/>

</xml_diff>